<commit_message>
Pitch deck: rebuilt from the 7aba833 eval; results slide lists only the copied lines that carry a percentage (#10)
</commit_message>
<xml_diff>
--- a/docs/pitch/Ghostwalk_pitch.pptx
+++ b/docs/pitch/Ghostwalk_pitch.pptx
@@ -118,14 +118,14 @@
   <p:extLst>
     <p:ext uri="{521415D9-36F7-43E2-AB2F-B90AF26B5E84}">
       <p14:sectionLst xmlns:p14="http://schemas.microsoft.com/office/powerpoint/2010/main">
-        <p14:section name="Problem" id="{54f7f4bf-2504-dd7f-81ef-d7ee17f3c9f3}">
+        <p14:section name="Problem" id="{8b9e4015-7b20-1162-0736-6ddc12ed28bf}">
           <p14:sldIdLst>
             <p14:sldId id="256"/>
             <p14:sldId id="257"/>
             <p14:sldId id="258"/>
           </p14:sldIdLst>
         </p14:section>
-        <p14:section name="Solution" id="{2baf3c19-d19d-31da-0801-3bdf2346172d}">
+        <p14:section name="Solution" id="{e633ba4b-c8e9-8498-3fc4-90b074436c19}">
           <p14:sldIdLst>
             <p14:sldId id="259"/>
             <p14:sldId id="260"/>
@@ -134,14 +134,14 @@
             <p14:sldId id="263"/>
           </p14:sldIdLst>
         </p14:section>
-        <p14:section name="Evidence" id="{6c2011a5-732b-9819-fc4b-b37209c61794}">
+        <p14:section name="Evidence" id="{9596606c-c448-4125-a059-10013d6df4e9}">
           <p14:sldIdLst>
             <p14:sldId id="264"/>
             <p14:sldId id="265"/>
             <p14:sldId id="266"/>
           </p14:sldIdLst>
         </p14:section>
-        <p14:section name="Close" id="{4452cb72-1316-5064-cf60-720b0125ceb0}">
+        <p14:section name="Close" id="{3774c6ce-7c0b-010c-ae97-0ab15fc15065}">
           <p14:sldIdLst>
             <p14:sldId id="267"/>
           </p14:sldIdLst>
@@ -583,307 +583,307 @@
                 <c:formatCode>General</c:formatCode>
                 <c:ptCount val="101"/>
                 <c:pt idx="0">
-                  <c:v>92.518</c:v>
+                  <c:v>92.2</c:v>
                 </c:pt>
                 <c:pt idx="1">
-                  <c:v>91.107</c:v>
+                  <c:v>91.799</c:v>
                 </c:pt>
                 <c:pt idx="2">
-                  <c:v>91.971</c:v>
+                  <c:v>90.929</c:v>
                 </c:pt>
                 <c:pt idx="3">
-                  <c:v>90.788</c:v>
+                  <c:v>91.085</c:v>
                 </c:pt>
                 <c:pt idx="4">
-                  <c:v>90.876</c:v>
+                  <c:v>90.48</c:v>
                 </c:pt>
                 <c:pt idx="5">
-                  <c:v>90.306</c:v>
+                  <c:v>89.86</c:v>
                 </c:pt>
                 <c:pt idx="6">
-                  <c:v>89.059</c:v>
+                  <c:v>88.002</c:v>
                 </c:pt>
                 <c:pt idx="7">
-                  <c:v>89.502</c:v>
+                  <c:v>89.408</c:v>
                 </c:pt>
                 <c:pt idx="8">
-                  <c:v>89.776</c:v>
+                  <c:v>89.027</c:v>
                 </c:pt>
                 <c:pt idx="9">
-                  <c:v>87.851</c:v>
+                  <c:v>88.317</c:v>
                 </c:pt>
                 <c:pt idx="10">
-                  <c:v>88.265</c:v>
+                  <c:v>86.832</c:v>
                 </c:pt>
                 <c:pt idx="11">
-                  <c:v>87.291</c:v>
+                  <c:v>85.997</c:v>
                 </c:pt>
                 <c:pt idx="12">
-                  <c:v>86.903</c:v>
+                  <c:v>85.946</c:v>
                 </c:pt>
                 <c:pt idx="13">
-                  <c:v>86.828</c:v>
+                  <c:v>84.449</c:v>
                 </c:pt>
                 <c:pt idx="14">
-                  <c:v>87.036</c:v>
+                  <c:v>84.859</c:v>
                 </c:pt>
                 <c:pt idx="15">
-                  <c:v>86.892</c:v>
+                  <c:v>84.839</c:v>
                 </c:pt>
                 <c:pt idx="16">
-                  <c:v>85.638</c:v>
+                  <c:v>84.49</c:v>
                 </c:pt>
                 <c:pt idx="17">
-                  <c:v>85.182</c:v>
+                  <c:v>84.249</c:v>
                 </c:pt>
                 <c:pt idx="18">
-                  <c:v>84.719</c:v>
+                  <c:v>84.056</c:v>
                 </c:pt>
                 <c:pt idx="19">
-                  <c:v>84.276</c:v>
+                  <c:v>83.944</c:v>
                 </c:pt>
                 <c:pt idx="20">
-                  <c:v>83.994</c:v>
+                  <c:v>83.476</c:v>
                 </c:pt>
                 <c:pt idx="21">
-                  <c:v>83.434</c:v>
+                  <c:v>83.549</c:v>
                 </c:pt>
                 <c:pt idx="22">
-                  <c:v>83.244</c:v>
+                  <c:v>83.264</c:v>
                 </c:pt>
                 <c:pt idx="23">
-                  <c:v>82.869</c:v>
+                  <c:v>83.086</c:v>
                 </c:pt>
                 <c:pt idx="24">
-                  <c:v>82.62</c:v>
+                  <c:v>82.6</c:v>
                 </c:pt>
                 <c:pt idx="25">
-                  <c:v>82.535</c:v>
+                  <c:v>82.24</c:v>
                 </c:pt>
                 <c:pt idx="26">
-                  <c:v>82.188</c:v>
+                  <c:v>82.172</c:v>
                 </c:pt>
                 <c:pt idx="27">
-                  <c:v>82.251</c:v>
+                  <c:v>82.267</c:v>
                 </c:pt>
                 <c:pt idx="28">
-                  <c:v>81.888</c:v>
+                  <c:v>82.128</c:v>
                 </c:pt>
                 <c:pt idx="29">
-                  <c:v>81.678</c:v>
+                  <c:v>81.807</c:v>
                 </c:pt>
                 <c:pt idx="30">
-                  <c:v>81.541</c:v>
+                  <c:v>81.61</c:v>
                 </c:pt>
                 <c:pt idx="31">
-                  <c:v>81.372</c:v>
+                  <c:v>81.41</c:v>
                 </c:pt>
                 <c:pt idx="32">
-                  <c:v>81.25</c:v>
+                  <c:v>81.374</c:v>
                 </c:pt>
                 <c:pt idx="33">
-                  <c:v>81.362</c:v>
+                  <c:v>81.26</c:v>
                 </c:pt>
                 <c:pt idx="34">
-                  <c:v>81.224</c:v>
+                  <c:v>81.208</c:v>
                 </c:pt>
                 <c:pt idx="35">
-                  <c:v>81.173</c:v>
+                  <c:v>81.19</c:v>
                 </c:pt>
                 <c:pt idx="36">
-                  <c:v>81.188</c:v>
+                  <c:v>81.183</c:v>
                 </c:pt>
                 <c:pt idx="37">
-                  <c:v>81.105</c:v>
+                  <c:v>81.159</c:v>
                 </c:pt>
                 <c:pt idx="38">
-                  <c:v>80.926</c:v>
+                  <c:v>81.1</c:v>
                 </c:pt>
                 <c:pt idx="39">
-                  <c:v>80.9</c:v>
+                  <c:v>81.028</c:v>
                 </c:pt>
                 <c:pt idx="40">
-                  <c:v>80.783</c:v>
+                  <c:v>80.894</c:v>
                 </c:pt>
                 <c:pt idx="41">
-                  <c:v>80.694</c:v>
+                  <c:v>80.86</c:v>
                 </c:pt>
                 <c:pt idx="42">
-                  <c:v>80.65</c:v>
+                  <c:v>80.743</c:v>
                 </c:pt>
                 <c:pt idx="43">
-                  <c:v>80.456</c:v>
+                  <c:v>80.647</c:v>
                 </c:pt>
                 <c:pt idx="44">
-                  <c:v>80.403</c:v>
+                  <c:v>80.588</c:v>
                 </c:pt>
                 <c:pt idx="45">
-                  <c:v>80.42</c:v>
+                  <c:v>80.528</c:v>
                 </c:pt>
                 <c:pt idx="46">
-                  <c:v>80.393</c:v>
+                  <c:v>80.516</c:v>
                 </c:pt>
                 <c:pt idx="47">
-                  <c:v>80.369</c:v>
+                  <c:v>80.517</c:v>
                 </c:pt>
                 <c:pt idx="48">
-                  <c:v>80.374</c:v>
+                  <c:v>80.481</c:v>
                 </c:pt>
                 <c:pt idx="49">
-                  <c:v>80.364</c:v>
+                  <c:v>80.454</c:v>
                 </c:pt>
                 <c:pt idx="50">
-                  <c:v>80.356</c:v>
+                  <c:v>80.439</c:v>
                 </c:pt>
                 <c:pt idx="51">
-                  <c:v>80.318</c:v>
+                  <c:v>80.409</c:v>
                 </c:pt>
                 <c:pt idx="52">
-                  <c:v>80.28</c:v>
+                  <c:v>80.358</c:v>
                 </c:pt>
                 <c:pt idx="53">
-                  <c:v>80.262</c:v>
+                  <c:v>80.338</c:v>
                 </c:pt>
                 <c:pt idx="54">
-                  <c:v>80.244</c:v>
+                  <c:v>80.328</c:v>
                 </c:pt>
                 <c:pt idx="55">
-                  <c:v>80.225</c:v>
+                  <c:v>80.311</c:v>
                 </c:pt>
                 <c:pt idx="56">
-                  <c:v>80.2</c:v>
+                  <c:v>80.306</c:v>
                 </c:pt>
                 <c:pt idx="57">
-                  <c:v>80.139</c:v>
+                  <c:v>80.301</c:v>
                 </c:pt>
                 <c:pt idx="58">
-                  <c:v>80.141</c:v>
+                  <c:v>80.296</c:v>
                 </c:pt>
                 <c:pt idx="59">
-                  <c:v>80.141</c:v>
+                  <c:v>80.296</c:v>
                 </c:pt>
                 <c:pt idx="60">
-                  <c:v>80.13</c:v>
+                  <c:v>80.299</c:v>
                 </c:pt>
                 <c:pt idx="61">
-                  <c:v>80.125</c:v>
+                  <c:v>80.294</c:v>
                 </c:pt>
                 <c:pt idx="62">
-                  <c:v>80.099</c:v>
+                  <c:v>80.294</c:v>
                 </c:pt>
                 <c:pt idx="63">
-                  <c:v>80.064</c:v>
+                  <c:v>80.277</c:v>
                 </c:pt>
                 <c:pt idx="64">
-                  <c:v>80.064</c:v>
+                  <c:v>80.253</c:v>
                 </c:pt>
                 <c:pt idx="65">
-                  <c:v>80.064</c:v>
+                  <c:v>80.226</c:v>
                 </c:pt>
                 <c:pt idx="66">
-                  <c:v>80.06</c:v>
+                  <c:v>80.226</c:v>
                 </c:pt>
                 <c:pt idx="67">
-                  <c:v>80.059</c:v>
+                  <c:v>80.205</c:v>
                 </c:pt>
                 <c:pt idx="68">
-                  <c:v>80.041</c:v>
+                  <c:v>80.155</c:v>
                 </c:pt>
                 <c:pt idx="69">
-                  <c:v>80.031</c:v>
+                  <c:v>80.138</c:v>
                 </c:pt>
                 <c:pt idx="70">
+                  <c:v>80.138</c:v>
+                </c:pt>
+                <c:pt idx="71">
+                  <c:v>80.1</c:v>
+                </c:pt>
+                <c:pt idx="72">
+                  <c:v>80.1</c:v>
+                </c:pt>
+                <c:pt idx="73">
+                  <c:v>80.086</c:v>
+                </c:pt>
+                <c:pt idx="74">
+                  <c:v>80.08</c:v>
+                </c:pt>
+                <c:pt idx="75">
+                  <c:v>80.05</c:v>
+                </c:pt>
+                <c:pt idx="76">
+                  <c:v>80.049</c:v>
+                </c:pt>
+                <c:pt idx="77">
                   <c:v>80.034</c:v>
                 </c:pt>
-                <c:pt idx="71">
-                  <c:v>80.017</c:v>
-                </c:pt>
-                <c:pt idx="72">
-                  <c:v>80.008</c:v>
-                </c:pt>
-                <c:pt idx="73">
-                  <c:v>80.008</c:v>
-                </c:pt>
-                <c:pt idx="74">
-                  <c:v>79.989</c:v>
-                </c:pt>
-                <c:pt idx="75">
-                  <c:v>79.989</c:v>
-                </c:pt>
-                <c:pt idx="76">
-                  <c:v>79.986</c:v>
-                </c:pt>
-                <c:pt idx="77">
-                  <c:v>79.979</c:v>
-                </c:pt>
                 <c:pt idx="78">
-                  <c:v>79.969</c:v>
+                  <c:v>80.025</c:v>
                 </c:pt>
                 <c:pt idx="79">
-                  <c:v>79.966</c:v>
+                  <c:v>80.025</c:v>
                 </c:pt>
                 <c:pt idx="80">
-                  <c:v>79.966</c:v>
+                  <c:v>80.024</c:v>
                 </c:pt>
                 <c:pt idx="81">
-                  <c:v>79.959</c:v>
+                  <c:v>80.018</c:v>
                 </c:pt>
                 <c:pt idx="82">
-                  <c:v>79.959</c:v>
+                  <c:v>80.018</c:v>
                 </c:pt>
                 <c:pt idx="83">
-                  <c:v>79.948</c:v>
+                  <c:v>80.006</c:v>
                 </c:pt>
                 <c:pt idx="84">
-                  <c:v>79.94</c:v>
+                  <c:v>79.972</c:v>
                 </c:pt>
                 <c:pt idx="85">
-                  <c:v>79.94</c:v>
+                  <c:v>79.972</c:v>
                 </c:pt>
                 <c:pt idx="86">
-                  <c:v>79.94</c:v>
+                  <c:v>79.931</c:v>
                 </c:pt>
                 <c:pt idx="87">
-                  <c:v>79.937</c:v>
+                  <c:v>79.931</c:v>
                 </c:pt>
                 <c:pt idx="88">
-                  <c:v>79.937</c:v>
+                  <c:v>79.931</c:v>
                 </c:pt>
                 <c:pt idx="89">
-                  <c:v>79.937</c:v>
+                  <c:v>79.931</c:v>
                 </c:pt>
                 <c:pt idx="90">
-                  <c:v>79.937</c:v>
+                  <c:v>79.929</c:v>
                 </c:pt>
                 <c:pt idx="91">
-                  <c:v>79.937</c:v>
+                  <c:v>79.929</c:v>
                 </c:pt>
                 <c:pt idx="92">
-                  <c:v>79.937</c:v>
+                  <c:v>79.929</c:v>
                 </c:pt>
                 <c:pt idx="93">
-                  <c:v>79.937</c:v>
+                  <c:v>79.93</c:v>
                 </c:pt>
                 <c:pt idx="94">
-                  <c:v>79.937</c:v>
+                  <c:v>79.93</c:v>
                 </c:pt>
                 <c:pt idx="95">
-                  <c:v>79.937</c:v>
+                  <c:v>79.92</c:v>
                 </c:pt>
                 <c:pt idx="96">
-                  <c:v>79.937</c:v>
+                  <c:v>79.92</c:v>
                 </c:pt>
                 <c:pt idx="97">
-                  <c:v>79.937</c:v>
+                  <c:v>79.92</c:v>
                 </c:pt>
                 <c:pt idx="98">
-                  <c:v>79.937</c:v>
+                  <c:v>79.92</c:v>
                 </c:pt>
                 <c:pt idx="99">
-                  <c:v>79.937</c:v>
+                  <c:v>79.92</c:v>
                 </c:pt>
                 <c:pt idx="100">
-                  <c:v>79.937</c:v>
+                  <c:v>79.914</c:v>
                 </c:pt>
               </c:numCache>
             </c:numRef>
@@ -1279,307 +1279,307 @@
                 <c:formatCode>General</c:formatCode>
                 <c:ptCount val="101"/>
                 <c:pt idx="0">
-                  <c:v>92.518</c:v>
+                  <c:v>92.2</c:v>
                 </c:pt>
                 <c:pt idx="1">
-                  <c:v>90.494</c:v>
+                  <c:v>90.792</c:v>
                 </c:pt>
                 <c:pt idx="2">
-                  <c:v>90.494</c:v>
+                  <c:v>90.46</c:v>
                 </c:pt>
                 <c:pt idx="3">
-                  <c:v>90.494</c:v>
+                  <c:v>90.278</c:v>
                 </c:pt>
                 <c:pt idx="4">
-                  <c:v>89.37</c:v>
+                  <c:v>89.389</c:v>
                 </c:pt>
                 <c:pt idx="5">
-                  <c:v>89.37</c:v>
+                  <c:v>88.491</c:v>
                 </c:pt>
                 <c:pt idx="6">
-                  <c:v>88.408</c:v>
+                  <c:v>87.351</c:v>
                 </c:pt>
                 <c:pt idx="7">
-                  <c:v>87.784</c:v>
+                  <c:v>87.351</c:v>
                 </c:pt>
                 <c:pt idx="8">
-                  <c:v>87.784</c:v>
+                  <c:v>87.351</c:v>
                 </c:pt>
                 <c:pt idx="9">
-                  <c:v>87.784</c:v>
+                  <c:v>87.351</c:v>
                 </c:pt>
                 <c:pt idx="10">
-                  <c:v>87.574</c:v>
+                  <c:v>86.651</c:v>
                 </c:pt>
                 <c:pt idx="11">
-                  <c:v>87.22</c:v>
+                  <c:v>85.767</c:v>
                 </c:pt>
                 <c:pt idx="12">
-                  <c:v>86.815</c:v>
+                  <c:v>85.559</c:v>
                 </c:pt>
                 <c:pt idx="13">
-                  <c:v>86.603</c:v>
+                  <c:v>84.402</c:v>
                 </c:pt>
                 <c:pt idx="14">
-                  <c:v>86.603</c:v>
+                  <c:v>83.936</c:v>
                 </c:pt>
                 <c:pt idx="15">
-                  <c:v>86.603</c:v>
+                  <c:v>83.936</c:v>
                 </c:pt>
                 <c:pt idx="16">
-                  <c:v>85.567</c:v>
+                  <c:v>83.936</c:v>
                 </c:pt>
                 <c:pt idx="17">
-                  <c:v>85.154</c:v>
+                  <c:v>83.936</c:v>
                 </c:pt>
                 <c:pt idx="18">
-                  <c:v>84.591</c:v>
+                  <c:v>83.936</c:v>
                 </c:pt>
                 <c:pt idx="19">
-                  <c:v>84.273</c:v>
+                  <c:v>83.851</c:v>
                 </c:pt>
                 <c:pt idx="20">
-                  <c:v>83.981</c:v>
+                  <c:v>83.476</c:v>
                 </c:pt>
                 <c:pt idx="21">
-                  <c:v>83.337</c:v>
+                  <c:v>83.18</c:v>
                 </c:pt>
                 <c:pt idx="22">
-                  <c:v>83.136</c:v>
+                  <c:v>83.135</c:v>
                 </c:pt>
                 <c:pt idx="23">
-                  <c:v>82.869</c:v>
+                  <c:v>83.017</c:v>
                 </c:pt>
                 <c:pt idx="24">
-                  <c:v>82.606</c:v>
+                  <c:v>82.6</c:v>
                 </c:pt>
                 <c:pt idx="25">
-                  <c:v>82.47</c:v>
+                  <c:v>82.198</c:v>
                 </c:pt>
                 <c:pt idx="26">
-                  <c:v>82.188</c:v>
+                  <c:v>82.172</c:v>
                 </c:pt>
                 <c:pt idx="27">
-                  <c:v>82.13</c:v>
+                  <c:v>82.138</c:v>
                 </c:pt>
                 <c:pt idx="28">
-                  <c:v>81.888</c:v>
+                  <c:v>82.128</c:v>
                 </c:pt>
                 <c:pt idx="29">
-                  <c:v>81.678</c:v>
+                  <c:v>81.807</c:v>
                 </c:pt>
                 <c:pt idx="30">
-                  <c:v>81.541</c:v>
+                  <c:v>81.61</c:v>
                 </c:pt>
                 <c:pt idx="31">
-                  <c:v>81.372</c:v>
+                  <c:v>81.389</c:v>
                 </c:pt>
                 <c:pt idx="32">
-                  <c:v>81.22</c:v>
+                  <c:v>81.357</c:v>
                 </c:pt>
                 <c:pt idx="33">
-                  <c:v>81.22</c:v>
+                  <c:v>81.238</c:v>
                 </c:pt>
                 <c:pt idx="34">
-                  <c:v>81.215</c:v>
+                  <c:v>81.208</c:v>
                 </c:pt>
                 <c:pt idx="35">
-                  <c:v>81.164</c:v>
+                  <c:v>81.174</c:v>
                 </c:pt>
                 <c:pt idx="36">
-                  <c:v>81.164</c:v>
+                  <c:v>81.174</c:v>
                 </c:pt>
                 <c:pt idx="37">
-                  <c:v>81.088</c:v>
+                  <c:v>81.142</c:v>
                 </c:pt>
                 <c:pt idx="38">
-                  <c:v>80.901</c:v>
+                  <c:v>81.085</c:v>
                 </c:pt>
                 <c:pt idx="39">
-                  <c:v>80.9</c:v>
+                  <c:v>81.028</c:v>
                 </c:pt>
                 <c:pt idx="40">
-                  <c:v>80.783</c:v>
+                  <c:v>80.894</c:v>
                 </c:pt>
                 <c:pt idx="41">
-                  <c:v>80.682</c:v>
+                  <c:v>80.86</c:v>
                 </c:pt>
                 <c:pt idx="42">
-                  <c:v>80.65</c:v>
+                  <c:v>80.743</c:v>
                 </c:pt>
                 <c:pt idx="43">
-                  <c:v>80.456</c:v>
+                  <c:v>80.644</c:v>
                 </c:pt>
                 <c:pt idx="44">
+                  <c:v>80.577</c:v>
+                </c:pt>
+                <c:pt idx="45">
+                  <c:v>80.516</c:v>
+                </c:pt>
+                <c:pt idx="46">
+                  <c:v>80.516</c:v>
+                </c:pt>
+                <c:pt idx="47">
+                  <c:v>80.514</c:v>
+                </c:pt>
+                <c:pt idx="48">
+                  <c:v>80.479</c:v>
+                </c:pt>
+                <c:pt idx="49">
+                  <c:v>80.443</c:v>
+                </c:pt>
+                <c:pt idx="50">
+                  <c:v>80.439</c:v>
+                </c:pt>
+                <c:pt idx="51">
                   <c:v>80.403</c:v>
                 </c:pt>
-                <c:pt idx="45">
-                  <c:v>80.403</c:v>
-                </c:pt>
-                <c:pt idx="46">
-                  <c:v>80.393</c:v>
-                </c:pt>
-                <c:pt idx="47">
-                  <c:v>80.357</c:v>
-                </c:pt>
-                <c:pt idx="48">
-                  <c:v>80.357</c:v>
-                </c:pt>
-                <c:pt idx="49">
-                  <c:v>80.357</c:v>
-                </c:pt>
-                <c:pt idx="50">
-                  <c:v>80.356</c:v>
-                </c:pt>
-                <c:pt idx="51">
-                  <c:v>80.304</c:v>
-                </c:pt>
                 <c:pt idx="52">
-                  <c:v>80.28</c:v>
+                  <c:v>80.358</c:v>
                 </c:pt>
                 <c:pt idx="53">
-                  <c:v>80.252</c:v>
+                  <c:v>80.331</c:v>
                 </c:pt>
                 <c:pt idx="54">
-                  <c:v>80.244</c:v>
+                  <c:v>80.328</c:v>
                 </c:pt>
                 <c:pt idx="55">
-                  <c:v>80.225</c:v>
+                  <c:v>80.308</c:v>
                 </c:pt>
                 <c:pt idx="56">
-                  <c:v>80.2</c:v>
+                  <c:v>80.306</c:v>
                 </c:pt>
                 <c:pt idx="57">
-                  <c:v>80.139</c:v>
+                  <c:v>80.301</c:v>
                 </c:pt>
                 <c:pt idx="58">
-                  <c:v>80.139</c:v>
+                  <c:v>80.296</c:v>
                 </c:pt>
                 <c:pt idx="59">
-                  <c:v>80.139</c:v>
+                  <c:v>80.296</c:v>
                 </c:pt>
                 <c:pt idx="60">
-                  <c:v>80.13</c:v>
+                  <c:v>80.296</c:v>
                 </c:pt>
                 <c:pt idx="61">
-                  <c:v>80.125</c:v>
+                  <c:v>80.294</c:v>
                 </c:pt>
                 <c:pt idx="62">
-                  <c:v>80.096</c:v>
+                  <c:v>80.294</c:v>
                 </c:pt>
                 <c:pt idx="63">
-                  <c:v>80.064</c:v>
+                  <c:v>80.277</c:v>
                 </c:pt>
                 <c:pt idx="64">
-                  <c:v>80.064</c:v>
+                  <c:v>80.253</c:v>
                 </c:pt>
                 <c:pt idx="65">
-                  <c:v>80.064</c:v>
+                  <c:v>80.226</c:v>
                 </c:pt>
                 <c:pt idx="66">
-                  <c:v>80.06</c:v>
+                  <c:v>80.226</c:v>
                 </c:pt>
                 <c:pt idx="67">
-                  <c:v>80.059</c:v>
+                  <c:v>80.205</c:v>
                 </c:pt>
                 <c:pt idx="68">
-                  <c:v>80.041</c:v>
+                  <c:v>80.155</c:v>
                 </c:pt>
                 <c:pt idx="69">
-                  <c:v>80.031</c:v>
+                  <c:v>80.138</c:v>
                 </c:pt>
                 <c:pt idx="70">
-                  <c:v>80.029</c:v>
+                  <c:v>80.138</c:v>
                 </c:pt>
                 <c:pt idx="71">
-                  <c:v>80.017</c:v>
+                  <c:v>80.1</c:v>
                 </c:pt>
                 <c:pt idx="72">
-                  <c:v>80.008</c:v>
+                  <c:v>80.1</c:v>
                 </c:pt>
                 <c:pt idx="73">
-                  <c:v>80.008</c:v>
+                  <c:v>80.086</c:v>
                 </c:pt>
                 <c:pt idx="74">
-                  <c:v>79.989</c:v>
+                  <c:v>80.08</c:v>
                 </c:pt>
                 <c:pt idx="75">
-                  <c:v>79.989</c:v>
+                  <c:v>80.05</c:v>
                 </c:pt>
                 <c:pt idx="76">
-                  <c:v>79.986</c:v>
+                  <c:v>80.049</c:v>
                 </c:pt>
                 <c:pt idx="77">
-                  <c:v>79.979</c:v>
+                  <c:v>80.034</c:v>
                 </c:pt>
                 <c:pt idx="78">
-                  <c:v>79.969</c:v>
+                  <c:v>80.025</c:v>
                 </c:pt>
                 <c:pt idx="79">
-                  <c:v>79.966</c:v>
+                  <c:v>80.025</c:v>
                 </c:pt>
                 <c:pt idx="80">
-                  <c:v>79.966</c:v>
+                  <c:v>80.024</c:v>
                 </c:pt>
                 <c:pt idx="81">
-                  <c:v>79.959</c:v>
+                  <c:v>80.018</c:v>
                 </c:pt>
                 <c:pt idx="82">
-                  <c:v>79.959</c:v>
+                  <c:v>80.018</c:v>
                 </c:pt>
                 <c:pt idx="83">
-                  <c:v>79.948</c:v>
+                  <c:v>80.006</c:v>
                 </c:pt>
                 <c:pt idx="84">
-                  <c:v>79.94</c:v>
+                  <c:v>79.972</c:v>
                 </c:pt>
                 <c:pt idx="85">
-                  <c:v>79.94</c:v>
+                  <c:v>79.972</c:v>
                 </c:pt>
                 <c:pt idx="86">
-                  <c:v>79.94</c:v>
+                  <c:v>79.931</c:v>
                 </c:pt>
                 <c:pt idx="87">
-                  <c:v>79.937</c:v>
+                  <c:v>79.931</c:v>
                 </c:pt>
                 <c:pt idx="88">
-                  <c:v>79.937</c:v>
+                  <c:v>79.931</c:v>
                 </c:pt>
                 <c:pt idx="89">
-                  <c:v>79.937</c:v>
+                  <c:v>79.931</c:v>
                 </c:pt>
                 <c:pt idx="90">
-                  <c:v>79.937</c:v>
+                  <c:v>79.929</c:v>
                 </c:pt>
                 <c:pt idx="91">
-                  <c:v>79.937</c:v>
+                  <c:v>79.929</c:v>
                 </c:pt>
                 <c:pt idx="92">
-                  <c:v>79.937</c:v>
+                  <c:v>79.929</c:v>
                 </c:pt>
                 <c:pt idx="93">
-                  <c:v>79.937</c:v>
+                  <c:v>79.929</c:v>
                 </c:pt>
                 <c:pt idx="94">
-                  <c:v>79.937</c:v>
+                  <c:v>79.929</c:v>
                 </c:pt>
                 <c:pt idx="95">
-                  <c:v>79.937</c:v>
+                  <c:v>79.92</c:v>
                 </c:pt>
                 <c:pt idx="96">
-                  <c:v>79.937</c:v>
+                  <c:v>79.92</c:v>
                 </c:pt>
                 <c:pt idx="97">
-                  <c:v>79.937</c:v>
+                  <c:v>79.92</c:v>
                 </c:pt>
                 <c:pt idx="98">
-                  <c:v>79.937</c:v>
+                  <c:v>79.92</c:v>
                 </c:pt>
                 <c:pt idx="99">
-                  <c:v>79.937</c:v>
+                  <c:v>79.92</c:v>
                 </c:pt>
                 <c:pt idx="100">
-                  <c:v>79.937</c:v>
+                  <c:v>79.914</c:v>
                 </c:pt>
               </c:numCache>
             </c:numRef>
@@ -13765,7 +13765,7 @@
                           <a:ea typeface="Calibri" pitchFamily="34" charset="-122"/>
                           <a:cs typeface="Calibri" pitchFamily="34" charset="-120"/>
                         </a:rPr>
-                        <a:t>+4.0%</a:t>
+                        <a:t>+4.3%</a:t>
                       </a:r>
                       <a:endParaRPr lang="en-US" sz="1300" dirty="0">
                         <a:latin typeface="Calibri" charset="0"/>
@@ -14243,7 +14243,7 @@
                           <a:ea typeface="Calibri" pitchFamily="34" charset="-122"/>
                           <a:cs typeface="Calibri" pitchFamily="34" charset="-120"/>
                         </a:rPr>
-                        <a:t>+8.0%</a:t>
+                        <a:t>+8.4%</a:t>
                       </a:r>
                       <a:endParaRPr lang="en-US" sz="1300" dirty="0">
                         <a:latin typeface="Calibri" charset="0"/>
@@ -14381,7 +14381,7 @@
                           <a:ea typeface="Calibri" pitchFamily="34" charset="-122"/>
                           <a:cs typeface="Calibri" pitchFamily="34" charset="-120"/>
                         </a:rPr>
-                        <a:t>92.52</a:t>
+                        <a:t>92.20</a:t>
                       </a:r>
                       <a:endParaRPr lang="en-US" sz="1300" dirty="0">
                         <a:latin typeface="Calibri" charset="0"/>
@@ -14449,7 +14449,7 @@
                           <a:ea typeface="Calibri" pitchFamily="34" charset="-122"/>
                           <a:cs typeface="Calibri" pitchFamily="34" charset="-120"/>
                         </a:rPr>
-                        <a:t>101.67</a:t>
+                        <a:t>101.71</a:t>
                       </a:r>
                       <a:endParaRPr lang="en-US" sz="1300" dirty="0">
                         <a:latin typeface="Calibri" charset="0"/>
@@ -14517,7 +14517,7 @@
                           <a:ea typeface="Calibri" pitchFamily="34" charset="-122"/>
                           <a:cs typeface="Calibri" pitchFamily="34" charset="-120"/>
                         </a:rPr>
-                        <a:t>125.2</a:t>
+                        <a:t>125.0</a:t>
                       </a:r>
                       <a:endParaRPr lang="en-US" sz="1300" dirty="0">
                         <a:latin typeface="Calibri" charset="0"/>
@@ -14585,7 +14585,7 @@
                           <a:ea typeface="Calibri" pitchFamily="34" charset="-122"/>
                           <a:cs typeface="Calibri" pitchFamily="34" charset="-120"/>
                         </a:rPr>
-                        <a:t>127.2</a:t>
+                        <a:t>127.3</a:t>
                       </a:r>
                       <a:endParaRPr lang="en-US" sz="1300" dirty="0">
                         <a:latin typeface="Calibri" charset="0"/>
@@ -14859,7 +14859,7 @@
                           <a:ea typeface="Calibri" pitchFamily="34" charset="-122"/>
                           <a:cs typeface="Calibri" pitchFamily="34" charset="-120"/>
                         </a:rPr>
-                        <a:t>79.94</a:t>
+                        <a:t>79.91</a:t>
                       </a:r>
                       <a:endParaRPr lang="en-US" sz="1300" dirty="0">
                         <a:latin typeface="Calibri" charset="0"/>
@@ -14927,7 +14927,7 @@
                           <a:ea typeface="Calibri" pitchFamily="34" charset="-122"/>
                           <a:cs typeface="Calibri" pitchFamily="34" charset="-120"/>
                         </a:rPr>
-                        <a:t>90.38</a:t>
+                        <a:t>90.40</a:t>
                       </a:r>
                       <a:endParaRPr lang="en-US" sz="1300" dirty="0">
                         <a:latin typeface="Calibri" charset="0"/>
@@ -15199,7 +15199,7 @@
                           <a:ea typeface="Calibri" pitchFamily="34" charset="-122"/>
                           <a:cs typeface="Calibri" pitchFamily="34" charset="-120"/>
                         </a:rPr>
-                        <a:t>−13.6%</a:t>
+                        <a:t>−13.3%</a:t>
                       </a:r>
                       <a:endParaRPr lang="en-US" sz="1300" dirty="0">
                         <a:latin typeface="Calibri" charset="0"/>
@@ -15292,7 +15292,7 @@
                 <a:ea typeface="Calibri" pitchFamily="34" charset="-122"/>
                 <a:cs typeface="Calibri" pitchFamily="34" charset="-120"/>
               </a:rPr>
-              <a:t>SA vs Baseline on train (in-sample): −13.6%, so in-sample → held-out shrinkage is 2.5 percentage points</a:t>
+              <a:t>SA vs Baseline on train (in-sample): −13.3%, so in-sample → held-out shrinkage is 2.2 percentage points</a:t>
             </a:r>
             <a:endParaRPr lang="en-US" sz="1400" dirty="0"/>
           </a:p>
@@ -15313,7 +15313,7 @@
                 <a:ea typeface="Calibri" pitchFamily="34" charset="-122"/>
                 <a:cs typeface="Calibri" pitchFamily="34" charset="-120"/>
               </a:rPr>
-              <a:t>Baseline vs Original, held-out: −3.9% (105.75 km → 101.67 km)</a:t>
+              <a:t>Baseline vs Original, held-out: −3.8% (105.75 km → 101.71 km)</a:t>
             </a:r>
             <a:endParaRPr lang="en-US" sz="1400" dirty="0"/>
           </a:p>
@@ -15334,7 +15334,7 @@
                 <a:ea typeface="Calibri" pitchFamily="34" charset="-122"/>
                 <a:cs typeface="Calibri" pitchFamily="34" charset="-120"/>
               </a:rPr>
-              <a:t>SA over seeds 42, 43, 44, 45, 46: held-out Δ vs Baseline −10.0% ± 0.9 pp (mean ± sd)</a:t>
+              <a:t>SA over seeds 42, 43, 44, 45, 46 (all at 30,000 iterations; seed 42 was fixed before the run): held-out Δ vs Baseline −10.0% ± 1.2 pp (mean ± sd)</a:t>
             </a:r>
             <a:endParaRPr lang="en-US" sz="1400" dirty="0"/>
           </a:p>
@@ -15355,7 +15355,7 @@
                 <a:ea typeface="Calibri" pitchFamily="34" charset="-122"/>
                 <a:cs typeface="Calibri" pitchFamily="34" charset="-120"/>
               </a:rPr>
-              <a:t>S-shape routing (ablation): Δ held-out vs Baseline (S-shape): −12.8%</a:t>
+              <a:t>S-shape routing (ablation): Δ held-out vs Baseline (S-shape): −11.8%</a:t>
             </a:r>
             <a:endParaRPr lang="en-US" sz="1400" dirty="0"/>
           </a:p>

</xml_diff>

<commit_message>
Deck and posts: live URL https://ghostwalk-tau.vercel.app; deck rebuilt (only the optional video URL pending)
Co-Authored-By: Claude Opus 5.5 <noreply@anthropic.com>
</commit_message>
<xml_diff>
--- a/docs/pitch/Ghostwalk_pitch.pptx
+++ b/docs/pitch/Ghostwalk_pitch.pptx
@@ -118,14 +118,14 @@
   <p:extLst>
     <p:ext uri="{521415D9-36F7-43E2-AB2F-B90AF26B5E84}">
       <p14:sectionLst xmlns:p14="http://schemas.microsoft.com/office/powerpoint/2010/main">
-        <p14:section name="Problem" id="{8b9e4015-7b20-1162-0736-6ddc12ed28bf}">
+        <p14:section name="Problem" id="{337044c1-f2fe-fdc9-ba7b-c860ea2f8b45}">
           <p14:sldIdLst>
             <p14:sldId id="256"/>
             <p14:sldId id="257"/>
             <p14:sldId id="258"/>
           </p14:sldIdLst>
         </p14:section>
-        <p14:section name="Solution" id="{e633ba4b-c8e9-8498-3fc4-90b074436c19}">
+        <p14:section name="Solution" id="{f34d8b61-6f6f-b797-811c-cd990afb1b6f}">
           <p14:sldIdLst>
             <p14:sldId id="259"/>
             <p14:sldId id="260"/>
@@ -134,14 +134,14 @@
             <p14:sldId id="263"/>
           </p14:sldIdLst>
         </p14:section>
-        <p14:section name="Evidence" id="{9596606c-c448-4125-a059-10013d6df4e9}">
+        <p14:section name="Evidence" id="{a46b3f44-222b-3f9e-bcef-f36ae170af80}">
           <p14:sldIdLst>
             <p14:sldId id="264"/>
             <p14:sldId id="265"/>
             <p14:sldId id="266"/>
           </p14:sldIdLst>
         </p14:section>
-        <p14:section name="Close" id="{3774c6ce-7c0b-010c-ae97-0ab15fc15065}">
+        <p14:section name="Close" id="{a4e3dfe9-b064-5dfb-e3db-0c3ac15b1e44}">
           <p14:sldIdLst>
             <p14:sldId id="267"/>
           </p14:sldIdLst>
@@ -5542,15 +5542,22 @@
               <a:buNone/>
             </a:pPr>
             <a:r>
-              <a:rPr lang="en-US" sz="1700" b="1" dirty="0">
-                <a:solidFill>
-                  <a:schemeClr val="bg1"/>
+              <a:rPr lang="en-US" sz="1700" b="1" u="sng" dirty="0">
+                <a:solidFill>
+                  <a:schemeClr val="accent2"/>
                 </a:solidFill>
                 <a:latin typeface="Calibri" pitchFamily="34" charset="0"/>
                 <a:ea typeface="Calibri" pitchFamily="34" charset="-122"/>
                 <a:cs typeface="Calibri" pitchFamily="34" charset="-120"/>
+                <a:hlinkClick r:id="rId2" invalidUrl="" action="" tgtFrame="" tooltip="" history="1" highlightClick="0" endSnd="0">
+                  <a:extLst>
+                    <a:ext uri="{A12FA001-AC4F-418D-AE19-62706E023703}">
+                      <ahyp:hlinkClr xmlns:ahyp="http://schemas.microsoft.com/office/drawing/2018/hyperlinkcolor" val="tx"/>
+                    </a:ext>
+                  </a:extLst>
+                </a:hlinkClick>
               </a:rPr>
-              <a:t>pending deploy</a:t>
+              <a:t>ghostwalk-tau.vercel.app</a:t>
             </a:r>
             <a:endParaRPr lang="en-US" sz="1700" dirty="0"/>
           </a:p>
@@ -5919,7 +5926,7 @@
           <p:nvPr/>
         </p:nvPicPr>
         <p:blipFill>
-          <a:blip r:embed="rId2"/>
+          <a:blip r:embed="rId3"/>
           <a:stretch>
             <a:fillRect/>
           </a:stretch>

</xml_diff>